<commit_message>
fix(exam-prep): rapikan minor hasil review deck
- notes: satu gaya (skrip ke peserta, arahan presenter dalam [Arahan: ...])
- notes slide 6-7: tunjuk quiz modul (*-quiz.html) sebagai bahan latihan
- slide 14: lokasi deck sertifikasi NCA-GENL
- slide 12-13: judul dan callout lebih luwes
- slide 4, 7, 12: font/baris diperbesar, ruang kosong berkurang
</commit_message>
<xml_diff>
--- a/docs/exam_prep_slides/exam_prep.pptx
+++ b/docs/exam_prep_slides/exam_prep.pptx
@@ -701,7 +701,7 @@
 Developer Forums: https://forums.developer.nvidia.com/
 Inception: https://www.nvidia.com/en-us/startups/
 Informasi ujian gratis untuk peserta GTC on-site ada di halaman training NVIDIA (https://www.nvidia.com/en-us/training/). Ketentuannya bisa berubah tiap tahun.
-Jetson AI Lab cocok untuk yang tertarik edge AI. Di modul NVIDIA kita sudah menjalankan LLM di Jetson Orin Nano. Inception relevan untuk peserta yang sedang atau ingin membangun startup; manfaat investor bergantung pada kelayakan.</a:t>
+Jetson AI Lab cocok untuk yang tertarik edge AI. Di modul NVIDIA kita sudah menjalankan LLM di Jetson Orin Nano. Inception relevan kalau kamu sedang atau ingin membangun startup; manfaat investor bergantung pada kelayakan.</a:t>
             </a:r>
             <a:endParaRPr lang="en-US" dirty="0"/>
           </a:p>
@@ -789,7 +789,7 @@
           <a:p>
             <a:r>
               <a:rPr lang="en-US" dirty="0"/>
-              <a:t>Tabel ini bukan daftar wajib. Tujuannya membantu peserta memilih satu arah dulu.
+              <a:t>Tabel ini bukan daftar wajib. Tujuannya membantu kamu memilih satu arah dulu.
 Sertifikasi di kolom tengah mengacu ke katalog NVIDIA: https://www.nvidia.com/en-us/learn/certification/ . Tanda panah artinya mulai dari Associate, lalu naik ke Professional.
 Proyek pertama sengaja dipilih yang bisa dimulai dari notebook bootcamp: agen RAG dari modul RAG, fine-tune SLM dari modul LLM, RAPIDS dari modul 01 dan 03, Triton dari modul NVIDIA, dan Jetson dari lab edge. Rekruter lebih mudah menilai satu proyek yang dalam dan terukur daripada lima sertifikat tanpa bukti kerja.</a:t>
             </a:r>
@@ -970,8 +970,8 @@
             <a:r>
               <a:rPr lang="en-US" dirty="0"/>
               <a:t>Lima langkah ini sengaja tanpa tanggal: urutannya yang penting, bukan kecepatannya.
-Tautan di kanan bisa diklik saat deck dibagikan. Deck NCA-GENL pendamping membahas kelima domain ujian satu per satu dan cocok dipakai sebagai bahan belajar mandiri.
-Tutup sesi dengan mengingatkan pesan pembuka: sertifikat itu satu langkah. Yang membuat kamu dipercaya adalah proyek yang bisa ditunjukkan dan dijelaskan.</a:t>
+Tautan di kanan bisa diklik saat deck dibagikan. Deck sertifikasi NCA-GENL (file nca_genl_slides.pdf, di repo: docs/nca_genl_slides/) membahas kelima domain ujian satu per satu dan cocok dipakai sebagai bahan belajar mandiri.
+[Arahan: tutup sesi dengan pesan pembuka.] Ingat lagi pesan di awal: sertifikat itu satu langkah. Yang membuat kamu dipercaya adalah proyek yang bisa ditunjukkan dan dijelaskan.</a:t>
             </a:r>
             <a:endParaRPr lang="en-US" dirty="0"/>
           </a:p>
@@ -1060,7 +1060,7 @@
             <a:r>
               <a:rPr lang="en-US" dirty="0"/>
               <a:t>Mulai dari apa yang sudah kamu bangun, bukan dari apa yang belum. Enam kotak ini merangkum isi modul 01 sampai 06. Hampir semua ini muncul di blueprint NCA-GENL.
-Minta peserta membuka lagi hasil pre-test mereka. Domain yang dulu nilainya paling rendah dan sekarang sudah dibahas di bootcamp adalah bukti kemajuan. Domain yang dulu rendah dan belum banyak dibahas adalah prioritas belajar berikutnya. Kita bahas petanya di slide 4.</a:t>
+[Arahan: minta peserta membuka hasil pre-test.] Buka lagi hasil pre-test kamu. Domain yang dulu nilainya paling rendah dan sekarang sudah dibahas di bootcamp adalah bukti kemajuan. Domain yang dulu rendah dan belum banyak dibahas adalah prioritas belajar berikutnya. Kita bahas petanya di slide 4.</a:t>
             </a:r>
             <a:endParaRPr lang="en-US" dirty="0"/>
           </a:p>
@@ -1151,7 +1151,7 @@
               <a:t>Semua angka di slide ini dari halaman resmi NCA-GENL. Dicek 24 September 2026.
 Sumber: https://www.nvidia.com/en-us/learn/certification/generative-ai-llm-associate/
 Level Associate, entry-level. Pendaftaran lewat tombol Register for Exam di halaman itu (platform Certiverse). Lulus mendapat digital badge dan sertifikat opsional. Setelah dua tahun, sertifikasi diperbarui dengan mengikuti ujian lagi.
-Soal passing score pasti ditanyakan. Jawabannya: NVIDIA tidak memublikasikannya. Angka batas lulus yang beredar di internet tidak punya dasar resmi. Strategi yang aman adalah menguasai materinya, bukan mengejar batas minimal. Ingatkan juga peserta untuk membaca examination policy NVIDIA sebelum menjadwalkan ujian.</a:t>
+Soal passing score pasti ditanyakan. Jawabannya: NVIDIA tidak memublikasikannya. Angka batas lulus yang beredar di internet tidak punya dasar resmi. Strategi yang aman adalah menguasai materinya, bukan mengejar batas minimal. Satu lagi: baca examination policy NVIDIA sebelum menjadwalkan ujian.</a:t>
             </a:r>
             <a:endParaRPr lang="en-US" dirty="0"/>
           </a:p>
@@ -1420,8 +1420,9 @@
             <a:r>
               <a:rPr lang="en-US" dirty="0"/>
               <a:t>Urutannya disusun berdasarkan pengaruhnya ke skor, bukan dari yang paling mudah. Domain berbobot besar yang masih lemah menyumbang paling banyak soal, jadi itu dulu.
-Langkah pertama berbeda untuk tiap orang. Experimentation lemah untuk semua peserta karena baru tercakup sebagian. Selain itu, hasil pre-test menunjukkan domain terlemahmu sendiri; kalau itu Core ML yang bobotnya 30%, dahulukan juga.
-Langkah terakhir penting karena soal ujian berbahasa Inggris. Membiasakan diri membaca soal pilihan ganda teknis dalam bahasa Inggris sama pentingnya dengan menguasai materinya.</a:t>
+Langkah pertama berbeda untuk tiap orang. Experimentation jadi prioritas kita semua karena baru tercakup sebagian. Selain itu, hasil pre-test menunjukkan domain terlemahmu sendiri; kalau itu Core ML yang bobotnya 30%, dahulukan juga.
+Langkah terakhir penting karena soal ujian berbahasa Inggris. Membiasakan diri membaca soal pilihan ganda teknis dalam bahasa Inggris sama pentingnya dengan menguasai materinya.
+Bahan latihan yang sudah kamu punya: quiz tiap modul (file *-quiz.html di folder modul 01–06), misalnya llm-fundamentals-quiz.html dan nvidia-ecosystem-quiz.html.</a:t>
             </a:r>
             <a:endParaRPr lang="en-US" dirty="0"/>
           </a:p>
@@ -1512,7 +1513,8 @@
               <a:t>Taktik ini umum untuk ujian pilihan ganda berbatas waktu, disesuaikan dengan format NCA-GENL.
 Satu menit per soal berasal dari 60 menit untuk 50 sampai 60 soal. Kalau satu soal terasa buntu, pilih jawaban terbaik yang kamu punya lalu lanjut.
 Kata kunci seperti "most likely" atau "first" sering membedakan dua pilihan yang sama-sama benar secara teknis. Soal dengan "NOT" mudah terlewat kalau membaca terburu-buru.
-Soal tentang produk NVIDIA kemungkinan besar menanyakan fungsinya: mana untuk serving, mana untuk optimasi inferensi, mana untuk guardrails. Kamu sudah memakai hampir semuanya di bootcamp.</a:t>
+Soal tentang produk NVIDIA kemungkinan besar menanyakan fungsinya: mana untuk serving, mana untuk optimasi inferensi, mana untuk guardrails. Kamu sudah memakai hampir semuanya di bootcamp.
+Latih tempo satu menit per soal dengan quiz modul (*-quiz.html) sebelum hari ujian.</a:t>
             </a:r>
             <a:endParaRPr lang="en-US" dirty="0"/>
           </a:p>
@@ -1693,7 +1695,7 @@
               <a:rPr lang="en-US" dirty="0"/>
               <a:t>Deep Learning Institute adalah unit pelatihan resmi NVIDIA. Dicek 24 September 2026.
 Sumber: https://www.nvidia.com/en-us/training/self-paced-courses/ dan https://www.nvidia.com/en-us/learn/certification/generative-ai-llm-associate/
-Halaman self-paced punya filter Free Courses. Sarankan peserta mulai dari yang gratis. Harga $90 dan $500 di slide adalah harga kursus yang direkomendasikan untuk NCA-GENL, bukan harga semua kursus DLI.
+Halaman self-paced punya filter Free Courses. Mulai dari yang gratis. Harga $90 dan $500 di slide adalah harga kursus yang direkomendasikan untuk NCA-GENL, bukan harga semua kursus DLI.
 Di halaman NCA-GENL, NVIDIA memetakan kursus-kursus ini ke domain ujian. Sebelum membeli, cek silabusnya: pilih yang menutup domain terlemahmu.</a:t>
             </a:r>
             <a:endParaRPr lang="en-US" dirty="0"/>
@@ -3711,7 +3713,7 @@
                 <a:ea typeface="Calibri" pitchFamily="34" charset="-122"/>
                 <a:cs typeface="Calibri" pitchFamily="34" charset="-120"/>
               </a:rPr>
-              <a:t>Pilih arah perannya dulu</a:t>
+              <a:t>Pilih dulu arah peranmu</a:t>
             </a:r>
             <a:endParaRPr lang="en-US" sz="3000" dirty="0"/>
           </a:p>
@@ -3783,7 +3785,7 @@
                 <a:gridCol w="2926080"/>
                 <a:gridCol w="4754880"/>
               </a:tblGrid>
-              <a:tr h="0">
+              <a:tr h="640080">
                 <a:tc>
                   <a:txBody>
                     <a:bodyPr/>
@@ -3793,7 +3795,7 @@
                         <a:buNone/>
                       </a:pPr>
                       <a:r>
-                        <a:rPr lang="en-US" sz="1500" b="1" dirty="0">
+                        <a:rPr lang="en-US" sz="1700" b="1" dirty="0">
                           <a:solidFill>
                             <a:srgbClr val="1A1A2E"/>
                           </a:solidFill>
@@ -3803,7 +3805,7 @@
                         </a:rPr>
                         <a:t>Peran</a:t>
                       </a:r>
-                      <a:endParaRPr lang="en-US" sz="1500" dirty="0">
+                      <a:endParaRPr lang="en-US" sz="1700" dirty="0">
                         <a:latin typeface="Calibri" charset="0"/>
                         <a:ea typeface="Calibri" charset="0"/>
                         <a:cs typeface="Calibri" charset="0"/>
@@ -3861,7 +3863,7 @@
                         <a:buNone/>
                       </a:pPr>
                       <a:r>
-                        <a:rPr lang="en-US" sz="1500" b="1" dirty="0">
+                        <a:rPr lang="en-US" sz="1700" b="1" dirty="0">
                           <a:solidFill>
                             <a:srgbClr val="1A1A2E"/>
                           </a:solidFill>
@@ -3871,7 +3873,7 @@
                         </a:rPr>
                         <a:t>Sertifikasi berikutnya</a:t>
                       </a:r>
-                      <a:endParaRPr lang="en-US" sz="1500" dirty="0">
+                      <a:endParaRPr lang="en-US" sz="1700" dirty="0">
                         <a:latin typeface="Calibri" charset="0"/>
                         <a:ea typeface="Calibri" charset="0"/>
                         <a:cs typeface="Calibri" charset="0"/>
@@ -3929,7 +3931,7 @@
                         <a:buNone/>
                       </a:pPr>
                       <a:r>
-                        <a:rPr lang="en-US" sz="1500" b="1" dirty="0">
+                        <a:rPr lang="en-US" sz="1700" b="1" dirty="0">
                           <a:solidFill>
                             <a:srgbClr val="1A1A2E"/>
                           </a:solidFill>
@@ -3939,7 +3941,7 @@
                         </a:rPr>
                         <a:t>Proyek pertama</a:t>
                       </a:r>
-                      <a:endParaRPr lang="en-US" sz="1500" dirty="0">
+                      <a:endParaRPr lang="en-US" sz="1700" dirty="0">
                         <a:latin typeface="Calibri" charset="0"/>
                         <a:ea typeface="Calibri" charset="0"/>
                         <a:cs typeface="Calibri" charset="0"/>
@@ -3989,7 +3991,7 @@
                   </a:tcPr>
                 </a:tc>
               </a:tr>
-              <a:tr h="0">
+              <a:tr h="640080">
                 <a:tc>
                   <a:txBody>
                     <a:bodyPr/>
@@ -3999,7 +4001,7 @@
                         <a:buNone/>
                       </a:pPr>
                       <a:r>
-                        <a:rPr lang="en-US" sz="1500" dirty="0">
+                        <a:rPr lang="en-US" sz="1700" dirty="0">
                           <a:solidFill>
                             <a:srgbClr val="FFFFFF"/>
                           </a:solidFill>
@@ -4009,7 +4011,7 @@
                         </a:rPr>
                         <a:t>LLM / AI application engineer</a:t>
                       </a:r>
-                      <a:endParaRPr lang="en-US" sz="1500" dirty="0">
+                      <a:endParaRPr lang="en-US" sz="1700" dirty="0">
                         <a:latin typeface="Calibri" charset="0"/>
                         <a:ea typeface="Calibri" charset="0"/>
                         <a:cs typeface="Calibri" charset="0"/>
@@ -4067,7 +4069,7 @@
                         <a:buNone/>
                       </a:pPr>
                       <a:r>
-                        <a:rPr lang="en-US" sz="1500" dirty="0">
+                        <a:rPr lang="en-US" sz="1700" dirty="0">
                           <a:solidFill>
                             <a:srgbClr val="FFFFFF"/>
                           </a:solidFill>
@@ -4077,7 +4079,7 @@
                         </a:rPr>
                         <a:t>NCP-GENL, NCP-AAI</a:t>
                       </a:r>
-                      <a:endParaRPr lang="en-US" sz="1500" dirty="0">
+                      <a:endParaRPr lang="en-US" sz="1700" dirty="0">
                         <a:latin typeface="Calibri" charset="0"/>
                         <a:ea typeface="Calibri" charset="0"/>
                         <a:cs typeface="Calibri" charset="0"/>
@@ -4135,7 +4137,7 @@
                         <a:buNone/>
                       </a:pPr>
                       <a:r>
-                        <a:rPr lang="en-US" sz="1500" dirty="0">
+                        <a:rPr lang="en-US" sz="1700" dirty="0">
                           <a:solidFill>
                             <a:srgbClr val="FFFFFF"/>
                           </a:solidFill>
@@ -4145,7 +4147,7 @@
                         </a:rPr>
                         <a:t>Agen RAG dengan tool calling dan guardrails</a:t>
                       </a:r>
-                      <a:endParaRPr lang="en-US" sz="1500" dirty="0">
+                      <a:endParaRPr lang="en-US" sz="1700" dirty="0">
                         <a:latin typeface="Calibri" charset="0"/>
                         <a:ea typeface="Calibri" charset="0"/>
                         <a:cs typeface="Calibri" charset="0"/>
@@ -4195,7 +4197,7 @@
                   </a:tcPr>
                 </a:tc>
               </a:tr>
-              <a:tr h="0">
+              <a:tr h="640080">
                 <a:tc>
                   <a:txBody>
                     <a:bodyPr/>
@@ -4205,7 +4207,7 @@
                         <a:buNone/>
                       </a:pPr>
                       <a:r>
-                        <a:rPr lang="en-US" sz="1500" dirty="0">
+                        <a:rPr lang="en-US" sz="1700" dirty="0">
                           <a:solidFill>
                             <a:srgbClr val="FFFFFF"/>
                           </a:solidFill>
@@ -4215,7 +4217,7 @@
                         </a:rPr>
                         <a:t>ML engineer (fine-tune &amp; evaluasi)</a:t>
                       </a:r>
-                      <a:endParaRPr lang="en-US" sz="1500" dirty="0">
+                      <a:endParaRPr lang="en-US" sz="1700" dirty="0">
                         <a:latin typeface="Calibri" charset="0"/>
                         <a:ea typeface="Calibri" charset="0"/>
                         <a:cs typeface="Calibri" charset="0"/>
@@ -4273,7 +4275,7 @@
                         <a:buNone/>
                       </a:pPr>
                       <a:r>
-                        <a:rPr lang="en-US" sz="1500" dirty="0">
+                        <a:rPr lang="en-US" sz="1700" dirty="0">
                           <a:solidFill>
                             <a:srgbClr val="FFFFFF"/>
                           </a:solidFill>
@@ -4283,7 +4285,7 @@
                         </a:rPr>
                         <a:t>NCP-GENL</a:t>
                       </a:r>
-                      <a:endParaRPr lang="en-US" sz="1500" dirty="0">
+                      <a:endParaRPr lang="en-US" sz="1700" dirty="0">
                         <a:latin typeface="Calibri" charset="0"/>
                         <a:ea typeface="Calibri" charset="0"/>
                         <a:cs typeface="Calibri" charset="0"/>
@@ -4341,7 +4343,7 @@
                         <a:buNone/>
                       </a:pPr>
                       <a:r>
-                        <a:rPr lang="en-US" sz="1500" dirty="0">
+                        <a:rPr lang="en-US" sz="1700" dirty="0">
                           <a:solidFill>
                             <a:srgbClr val="FFFFFF"/>
                           </a:solidFill>
@@ -4351,7 +4353,7 @@
                         </a:rPr>
                         <a:t>Fine-tune SLM untuk satu tugas + laporan evaluasi</a:t>
                       </a:r>
-                      <a:endParaRPr lang="en-US" sz="1500" dirty="0">
+                      <a:endParaRPr lang="en-US" sz="1700" dirty="0">
                         <a:latin typeface="Calibri" charset="0"/>
                         <a:ea typeface="Calibri" charset="0"/>
                         <a:cs typeface="Calibri" charset="0"/>
@@ -4401,7 +4403,7 @@
                   </a:tcPr>
                 </a:tc>
               </a:tr>
-              <a:tr h="0">
+              <a:tr h="640080">
                 <a:tc>
                   <a:txBody>
                     <a:bodyPr/>
@@ -4411,7 +4413,7 @@
                         <a:buNone/>
                       </a:pPr>
                       <a:r>
-                        <a:rPr lang="en-US" sz="1500" dirty="0">
+                        <a:rPr lang="en-US" sz="1700" dirty="0">
                           <a:solidFill>
                             <a:srgbClr val="FFFFFF"/>
                           </a:solidFill>
@@ -4421,7 +4423,7 @@
                         </a:rPr>
                         <a:t>Data scientist</a:t>
                       </a:r>
-                      <a:endParaRPr lang="en-US" sz="1500" dirty="0">
+                      <a:endParaRPr lang="en-US" sz="1700" dirty="0">
                         <a:latin typeface="Calibri" charset="0"/>
                         <a:ea typeface="Calibri" charset="0"/>
                         <a:cs typeface="Calibri" charset="0"/>
@@ -4479,7 +4481,7 @@
                         <a:buNone/>
                       </a:pPr>
                       <a:r>
-                        <a:rPr lang="en-US" sz="1500" dirty="0">
+                        <a:rPr lang="en-US" sz="1700" dirty="0">
                           <a:solidFill>
                             <a:srgbClr val="FFFFFF"/>
                           </a:solidFill>
@@ -4489,7 +4491,7 @@
                         </a:rPr>
                         <a:t>NCA-ADS → NCP-ADS</a:t>
                       </a:r>
-                      <a:endParaRPr lang="en-US" sz="1500" dirty="0">
+                      <a:endParaRPr lang="en-US" sz="1700" dirty="0">
                         <a:latin typeface="Calibri" charset="0"/>
                         <a:ea typeface="Calibri" charset="0"/>
                         <a:cs typeface="Calibri" charset="0"/>
@@ -4547,7 +4549,7 @@
                         <a:buNone/>
                       </a:pPr>
                       <a:r>
-                        <a:rPr lang="en-US" sz="1500" dirty="0">
+                        <a:rPr lang="en-US" sz="1700" dirty="0">
                           <a:solidFill>
                             <a:srgbClr val="FFFFFF"/>
                           </a:solidFill>
@@ -4557,7 +4559,7 @@
                         </a:rPr>
                         <a:t>Pipeline cuDF/cuML di data nyata + benchmark CPU vs GPU</a:t>
                       </a:r>
-                      <a:endParaRPr lang="en-US" sz="1500" dirty="0">
+                      <a:endParaRPr lang="en-US" sz="1700" dirty="0">
                         <a:latin typeface="Calibri" charset="0"/>
                         <a:ea typeface="Calibri" charset="0"/>
                         <a:cs typeface="Calibri" charset="0"/>
@@ -4607,7 +4609,7 @@
                   </a:tcPr>
                 </a:tc>
               </a:tr>
-              <a:tr h="0">
+              <a:tr h="640080">
                 <a:tc>
                   <a:txBody>
                     <a:bodyPr/>
@@ -4617,7 +4619,7 @@
                         <a:buNone/>
                       </a:pPr>
                       <a:r>
-                        <a:rPr lang="en-US" sz="1500" dirty="0">
+                        <a:rPr lang="en-US" sz="1700" dirty="0">
                           <a:solidFill>
                             <a:srgbClr val="FFFFFF"/>
                           </a:solidFill>
@@ -4627,7 +4629,7 @@
                         </a:rPr>
                         <a:t>MLOps / AI infrastructure</a:t>
                       </a:r>
-                      <a:endParaRPr lang="en-US" sz="1500" dirty="0">
+                      <a:endParaRPr lang="en-US" sz="1700" dirty="0">
                         <a:latin typeface="Calibri" charset="0"/>
                         <a:ea typeface="Calibri" charset="0"/>
                         <a:cs typeface="Calibri" charset="0"/>
@@ -4685,7 +4687,7 @@
                         <a:buNone/>
                       </a:pPr>
                       <a:r>
-                        <a:rPr lang="en-US" sz="1500" dirty="0">
+                        <a:rPr lang="en-US" sz="1700" dirty="0">
                           <a:solidFill>
                             <a:srgbClr val="FFFFFF"/>
                           </a:solidFill>
@@ -4695,7 +4697,7 @@
                         </a:rPr>
                         <a:t>NCA-AIIO → NCP-AIO</a:t>
                       </a:r>
-                      <a:endParaRPr lang="en-US" sz="1500" dirty="0">
+                      <a:endParaRPr lang="en-US" sz="1700" dirty="0">
                         <a:latin typeface="Calibri" charset="0"/>
                         <a:ea typeface="Calibri" charset="0"/>
                         <a:cs typeface="Calibri" charset="0"/>
@@ -4753,7 +4755,7 @@
                         <a:buNone/>
                       </a:pPr>
                       <a:r>
-                        <a:rPr lang="en-US" sz="1500" dirty="0">
+                        <a:rPr lang="en-US" sz="1700" dirty="0">
                           <a:solidFill>
                             <a:srgbClr val="FFFFFF"/>
                           </a:solidFill>
@@ -4763,7 +4765,7 @@
                         </a:rPr>
                         <a:t>Serving model dengan Triton + pemantauan latensi</a:t>
                       </a:r>
-                      <a:endParaRPr lang="en-US" sz="1500" dirty="0">
+                      <a:endParaRPr lang="en-US" sz="1700" dirty="0">
                         <a:latin typeface="Calibri" charset="0"/>
                         <a:ea typeface="Calibri" charset="0"/>
                         <a:cs typeface="Calibri" charset="0"/>
@@ -4813,7 +4815,7 @@
                   </a:tcPr>
                 </a:tc>
               </a:tr>
-              <a:tr h="0">
+              <a:tr h="640080">
                 <a:tc>
                   <a:txBody>
                     <a:bodyPr/>
@@ -4823,7 +4825,7 @@
                         <a:buNone/>
                       </a:pPr>
                       <a:r>
-                        <a:rPr lang="en-US" sz="1500" dirty="0">
+                        <a:rPr lang="en-US" sz="1700" dirty="0">
                           <a:solidFill>
                             <a:srgbClr val="FFFFFF"/>
                           </a:solidFill>
@@ -4833,7 +4835,7 @@
                         </a:rPr>
                         <a:t>Edge AI engineer</a:t>
                       </a:r>
-                      <a:endParaRPr lang="en-US" sz="1500" dirty="0">
+                      <a:endParaRPr lang="en-US" sz="1700" dirty="0">
                         <a:latin typeface="Calibri" charset="0"/>
                         <a:ea typeface="Calibri" charset="0"/>
                         <a:cs typeface="Calibri" charset="0"/>
@@ -4891,7 +4893,7 @@
                         <a:buNone/>
                       </a:pPr>
                       <a:r>
-                        <a:rPr lang="en-US" sz="1500" dirty="0">
+                        <a:rPr lang="en-US" sz="1700" dirty="0">
                           <a:solidFill>
                             <a:srgbClr val="FFFFFF"/>
                           </a:solidFill>
@@ -4901,7 +4903,7 @@
                         </a:rPr>
                         <a:t>Belajar lewat Jetson AI Lab</a:t>
                       </a:r>
-                      <a:endParaRPr lang="en-US" sz="1500" dirty="0">
+                      <a:endParaRPr lang="en-US" sz="1700" dirty="0">
                         <a:latin typeface="Calibri" charset="0"/>
                         <a:ea typeface="Calibri" charset="0"/>
                         <a:cs typeface="Calibri" charset="0"/>
@@ -4959,7 +4961,7 @@
                         <a:buNone/>
                       </a:pPr>
                       <a:r>
-                        <a:rPr lang="en-US" sz="1500" dirty="0">
+                        <a:rPr lang="en-US" sz="1700" dirty="0">
                           <a:solidFill>
                             <a:srgbClr val="FFFFFF"/>
                           </a:solidFill>
@@ -4969,7 +4971,7 @@
                         </a:rPr>
                         <a:t>Asisten lokal di Jetson dengan Ollama atau TensorRT</a:t>
                       </a:r>
-                      <a:endParaRPr lang="en-US" sz="1500" dirty="0">
+                      <a:endParaRPr lang="en-US" sz="1700" dirty="0">
                         <a:latin typeface="Calibri" charset="0"/>
                         <a:ea typeface="Calibri" charset="0"/>
                         <a:cs typeface="Calibri" charset="0"/>
@@ -5853,7 +5855,7 @@
                 <a:ea typeface="Calibri" pitchFamily="34" charset="-122"/>
                 <a:cs typeface="Calibri" pitchFamily="34" charset="-120"/>
               </a:rPr>
-              <a:t>Capstone yang sudah jadi adalah bahan portofolio pertamamu. Tinggal dipublikasikan.</a:t>
+              <a:t>Capstone-mu sudah jadi bahan portofolio. Tinggal dikemas dan dipublikasikan.</a:t>
             </a:r>
             <a:endParaRPr lang="en-US" sz="1700" dirty="0"/>
           </a:p>
@@ -6530,8 +6532,8 @@
         </p:nvSpPr>
         <p:spPr>
           <a:xfrm>
-            <a:off x="6812280" y="5486400"/>
-            <a:ext cx="4572000" cy="365760"/>
+            <a:off x="6812280" y="5349240"/>
+            <a:ext cx="4572000" cy="548640"/>
           </a:xfrm>
           <a:prstGeom prst="rect">
             <a:avLst/>
@@ -6555,7 +6557,7 @@
                 <a:ea typeface="Calibri" pitchFamily="34" charset="-122"/>
                 <a:cs typeface="Calibri" pitchFamily="34" charset="-120"/>
               </a:rPr>
-              <a:t>Detail tiap domain: deck NCA-GENL (materi pendamping).</a:t>
+              <a:t>Detail tiap domain: deck sertifikasi NCA-GENL di folder materi bootcamp.</a:t>
             </a:r>
             <a:endParaRPr lang="en-US" sz="1300" dirty="0"/>
           </a:p>
@@ -8492,7 +8494,7 @@
                 <a:gridCol w="4572000"/>
                 <a:gridCol w="1554480"/>
               </a:tblGrid>
-              <a:tr h="0">
+              <a:tr h="594360">
                 <a:tc>
                   <a:txBody>
                     <a:bodyPr/>
@@ -8502,7 +8504,7 @@
                         <a:buNone/>
                       </a:pPr>
                       <a:r>
-                        <a:rPr lang="en-US" sz="1600" b="1" dirty="0">
+                        <a:rPr lang="en-US" sz="1900" b="1" dirty="0">
                           <a:solidFill>
                             <a:srgbClr val="1A1A2E"/>
                           </a:solidFill>
@@ -8512,7 +8514,7 @@
                         </a:rPr>
                         <a:t>Domain ujian</a:t>
                       </a:r>
-                      <a:endParaRPr lang="en-US" sz="1600" dirty="0">
+                      <a:endParaRPr lang="en-US" sz="1900" dirty="0">
                         <a:latin typeface="Calibri" charset="0"/>
                         <a:ea typeface="Calibri" charset="0"/>
                         <a:cs typeface="Calibri" charset="0"/>
@@ -8570,7 +8572,7 @@
                         <a:buNone/>
                       </a:pPr>
                       <a:r>
-                        <a:rPr lang="en-US" sz="1600" b="1" dirty="0">
+                        <a:rPr lang="en-US" sz="1900" b="1" dirty="0">
                           <a:solidFill>
                             <a:srgbClr val="1A1A2E"/>
                           </a:solidFill>
@@ -8580,7 +8582,7 @@
                         </a:rPr>
                         <a:t>Bobot</a:t>
                       </a:r>
-                      <a:endParaRPr lang="en-US" sz="1600" dirty="0">
+                      <a:endParaRPr lang="en-US" sz="1900" dirty="0">
                         <a:latin typeface="Calibri" charset="0"/>
                         <a:ea typeface="Calibri" charset="0"/>
                         <a:cs typeface="Calibri" charset="0"/>
@@ -8638,7 +8640,7 @@
                         <a:buNone/>
                       </a:pPr>
                       <a:r>
-                        <a:rPr lang="en-US" sz="1600" b="1" dirty="0">
+                        <a:rPr lang="en-US" sz="1900" b="1" dirty="0">
                           <a:solidFill>
                             <a:srgbClr val="1A1A2E"/>
                           </a:solidFill>
@@ -8648,7 +8650,7 @@
                         </a:rPr>
                         <a:t>Dibahas di modul</a:t>
                       </a:r>
-                      <a:endParaRPr lang="en-US" sz="1600" dirty="0">
+                      <a:endParaRPr lang="en-US" sz="1900" dirty="0">
                         <a:latin typeface="Calibri" charset="0"/>
                         <a:ea typeface="Calibri" charset="0"/>
                         <a:cs typeface="Calibri" charset="0"/>
@@ -8706,7 +8708,7 @@
                         <a:buNone/>
                       </a:pPr>
                       <a:r>
-                        <a:rPr lang="en-US" sz="1600" b="1" dirty="0">
+                        <a:rPr lang="en-US" sz="1900" b="1" dirty="0">
                           <a:solidFill>
                             <a:srgbClr val="1A1A2E"/>
                           </a:solidFill>
@@ -8716,7 +8718,7 @@
                         </a:rPr>
                         <a:t>Status</a:t>
                       </a:r>
-                      <a:endParaRPr lang="en-US" sz="1600" dirty="0">
+                      <a:endParaRPr lang="en-US" sz="1900" dirty="0">
                         <a:latin typeface="Calibri" charset="0"/>
                         <a:ea typeface="Calibri" charset="0"/>
                         <a:cs typeface="Calibri" charset="0"/>
@@ -8766,7 +8768,7 @@
                   </a:tcPr>
                 </a:tc>
               </a:tr>
-              <a:tr h="0">
+              <a:tr h="594360">
                 <a:tc>
                   <a:txBody>
                     <a:bodyPr/>
@@ -8776,7 +8778,7 @@
                         <a:buNone/>
                       </a:pPr>
                       <a:r>
-                        <a:rPr lang="en-US" sz="1600" dirty="0">
+                        <a:rPr lang="en-US" sz="1900" dirty="0">
                           <a:solidFill>
                             <a:srgbClr val="FFFFFF"/>
                           </a:solidFill>
@@ -8786,7 +8788,7 @@
                         </a:rPr>
                         <a:t>Core Machine Learning &amp; AI Knowledge</a:t>
                       </a:r>
-                      <a:endParaRPr lang="en-US" sz="1600" dirty="0">
+                      <a:endParaRPr lang="en-US" sz="1900" dirty="0">
                         <a:latin typeface="Calibri" charset="0"/>
                         <a:ea typeface="Calibri" charset="0"/>
                         <a:cs typeface="Calibri" charset="0"/>
@@ -8844,7 +8846,7 @@
                         <a:buNone/>
                       </a:pPr>
                       <a:r>
-                        <a:rPr lang="en-US" sz="1600" dirty="0">
+                        <a:rPr lang="en-US" sz="1900" dirty="0">
                           <a:solidFill>
                             <a:srgbClr val="FFFFFF"/>
                           </a:solidFill>
@@ -8854,7 +8856,7 @@
                         </a:rPr>
                         <a:t>30%</a:t>
                       </a:r>
-                      <a:endParaRPr lang="en-US" sz="1600" dirty="0">
+                      <a:endParaRPr lang="en-US" sz="1900" dirty="0">
                         <a:latin typeface="Calibri" charset="0"/>
                         <a:ea typeface="Calibri" charset="0"/>
                         <a:cs typeface="Calibri" charset="0"/>
@@ -8912,7 +8914,7 @@
                         <a:buNone/>
                       </a:pPr>
                       <a:r>
-                        <a:rPr lang="en-US" sz="1600" dirty="0">
+                        <a:rPr lang="en-US" sz="1900" dirty="0">
                           <a:solidFill>
                             <a:srgbClr val="FFFFFF"/>
                           </a:solidFill>
@@ -8922,7 +8924,7 @@
                         </a:rPr>
                         <a:t>M01 ML, M02 DL, M04 transformer &amp; LLM</a:t>
                       </a:r>
-                      <a:endParaRPr lang="en-US" sz="1600" dirty="0">
+                      <a:endParaRPr lang="en-US" sz="1900" dirty="0">
                         <a:latin typeface="Calibri" charset="0"/>
                         <a:ea typeface="Calibri" charset="0"/>
                         <a:cs typeface="Calibri" charset="0"/>
@@ -8980,7 +8982,7 @@
                         <a:buNone/>
                       </a:pPr>
                       <a:r>
-                        <a:rPr lang="en-US" sz="1600" b="1" dirty="0">
+                        <a:rPr lang="en-US" sz="1900" b="1" dirty="0">
                           <a:solidFill>
                             <a:srgbClr val="76B900"/>
                           </a:solidFill>
@@ -8990,7 +8992,7 @@
                         </a:rPr>
                         <a:t>Tercakup</a:t>
                       </a:r>
-                      <a:endParaRPr lang="en-US" sz="1600" dirty="0">
+                      <a:endParaRPr lang="en-US" sz="1900" dirty="0">
                         <a:latin typeface="Calibri" charset="0"/>
                         <a:ea typeface="Calibri" charset="0"/>
                         <a:cs typeface="Calibri" charset="0"/>
@@ -9040,7 +9042,7 @@
                   </a:tcPr>
                 </a:tc>
               </a:tr>
-              <a:tr h="0">
+              <a:tr h="594360">
                 <a:tc>
                   <a:txBody>
                     <a:bodyPr/>
@@ -9050,7 +9052,7 @@
                         <a:buNone/>
                       </a:pPr>
                       <a:r>
-                        <a:rPr lang="en-US" sz="1600" dirty="0">
+                        <a:rPr lang="en-US" sz="1900" dirty="0">
                           <a:solidFill>
                             <a:srgbClr val="FFFFFF"/>
                           </a:solidFill>
@@ -9060,7 +9062,7 @@
                         </a:rPr>
                         <a:t>Software Development</a:t>
                       </a:r>
-                      <a:endParaRPr lang="en-US" sz="1600" dirty="0">
+                      <a:endParaRPr lang="en-US" sz="1900" dirty="0">
                         <a:latin typeface="Calibri" charset="0"/>
                         <a:ea typeface="Calibri" charset="0"/>
                         <a:cs typeface="Calibri" charset="0"/>
@@ -9118,7 +9120,7 @@
                         <a:buNone/>
                       </a:pPr>
                       <a:r>
-                        <a:rPr lang="en-US" sz="1600" dirty="0">
+                        <a:rPr lang="en-US" sz="1900" dirty="0">
                           <a:solidFill>
                             <a:srgbClr val="FFFFFF"/>
                           </a:solidFill>
@@ -9128,7 +9130,7 @@
                         </a:rPr>
                         <a:t>24%</a:t>
                       </a:r>
-                      <a:endParaRPr lang="en-US" sz="1600" dirty="0">
+                      <a:endParaRPr lang="en-US" sz="1900" dirty="0">
                         <a:latin typeface="Calibri" charset="0"/>
                         <a:ea typeface="Calibri" charset="0"/>
                         <a:cs typeface="Calibri" charset="0"/>
@@ -9186,7 +9188,7 @@
                         <a:buNone/>
                       </a:pPr>
                       <a:r>
-                        <a:rPr lang="en-US" sz="1600" dirty="0">
+                        <a:rPr lang="en-US" sz="1900" dirty="0">
                           <a:solidFill>
                             <a:srgbClr val="FFFFFF"/>
                           </a:solidFill>
@@ -9196,7 +9198,7 @@
                         </a:rPr>
                         <a:t>M04 produksi LLM, M05 RAG API, M06 serving</a:t>
                       </a:r>
-                      <a:endParaRPr lang="en-US" sz="1600" dirty="0">
+                      <a:endParaRPr lang="en-US" sz="1900" dirty="0">
                         <a:latin typeface="Calibri" charset="0"/>
                         <a:ea typeface="Calibri" charset="0"/>
                         <a:cs typeface="Calibri" charset="0"/>
@@ -9254,7 +9256,7 @@
                         <a:buNone/>
                       </a:pPr>
                       <a:r>
-                        <a:rPr lang="en-US" sz="1600" b="1" dirty="0">
+                        <a:rPr lang="en-US" sz="1900" b="1" dirty="0">
                           <a:solidFill>
                             <a:srgbClr val="76B900"/>
                           </a:solidFill>
@@ -9264,7 +9266,7 @@
                         </a:rPr>
                         <a:t>Tercakup</a:t>
                       </a:r>
-                      <a:endParaRPr lang="en-US" sz="1600" dirty="0">
+                      <a:endParaRPr lang="en-US" sz="1900" dirty="0">
                         <a:latin typeface="Calibri" charset="0"/>
                         <a:ea typeface="Calibri" charset="0"/>
                         <a:cs typeface="Calibri" charset="0"/>
@@ -9314,7 +9316,7 @@
                   </a:tcPr>
                 </a:tc>
               </a:tr>
-              <a:tr h="0">
+              <a:tr h="594360">
                 <a:tc>
                   <a:txBody>
                     <a:bodyPr/>
@@ -9324,7 +9326,7 @@
                         <a:buNone/>
                       </a:pPr>
                       <a:r>
-                        <a:rPr lang="en-US" sz="1600" dirty="0">
+                        <a:rPr lang="en-US" sz="1900" dirty="0">
                           <a:solidFill>
                             <a:srgbClr val="FFFFFF"/>
                           </a:solidFill>
@@ -9334,7 +9336,7 @@
                         </a:rPr>
                         <a:t>Experimentation</a:t>
                       </a:r>
-                      <a:endParaRPr lang="en-US" sz="1600" dirty="0">
+                      <a:endParaRPr lang="en-US" sz="1900" dirty="0">
                         <a:latin typeface="Calibri" charset="0"/>
                         <a:ea typeface="Calibri" charset="0"/>
                         <a:cs typeface="Calibri" charset="0"/>
@@ -9392,7 +9394,7 @@
                         <a:buNone/>
                       </a:pPr>
                       <a:r>
-                        <a:rPr lang="en-US" sz="1600" dirty="0">
+                        <a:rPr lang="en-US" sz="1900" dirty="0">
                           <a:solidFill>
                             <a:srgbClr val="FFFFFF"/>
                           </a:solidFill>
@@ -9402,7 +9404,7 @@
                         </a:rPr>
                         <a:t>22%</a:t>
                       </a:r>
-                      <a:endParaRPr lang="en-US" sz="1600" dirty="0">
+                      <a:endParaRPr lang="en-US" sz="1900" dirty="0">
                         <a:latin typeface="Calibri" charset="0"/>
                         <a:ea typeface="Calibri" charset="0"/>
                         <a:cs typeface="Calibri" charset="0"/>
@@ -9460,7 +9462,7 @@
                         <a:buNone/>
                       </a:pPr>
                       <a:r>
-                        <a:rPr lang="en-US" sz="1600" dirty="0">
+                        <a:rPr lang="en-US" sz="1900" dirty="0">
                           <a:solidFill>
                             <a:srgbClr val="FFFFFF"/>
                           </a:solidFill>
@@ -9470,7 +9472,7 @@
                         </a:rPr>
                         <a:t>M04 LoRA &amp; evaluasi, M05 RAGAS</a:t>
                       </a:r>
-                      <a:endParaRPr lang="en-US" sz="1600" dirty="0">
+                      <a:endParaRPr lang="en-US" sz="1900" dirty="0">
                         <a:latin typeface="Calibri" charset="0"/>
                         <a:ea typeface="Calibri" charset="0"/>
                         <a:cs typeface="Calibri" charset="0"/>
@@ -9528,7 +9530,7 @@
                         <a:buNone/>
                       </a:pPr>
                       <a:r>
-                        <a:rPr lang="en-US" sz="1600" b="1" dirty="0">
+                        <a:rPr lang="en-US" sz="1900" b="1" dirty="0">
                           <a:solidFill>
                             <a:srgbClr val="FF6F00"/>
                           </a:solidFill>
@@ -9538,7 +9540,7 @@
                         </a:rPr>
                         <a:t>Sebagian</a:t>
                       </a:r>
-                      <a:endParaRPr lang="en-US" sz="1600" dirty="0">
+                      <a:endParaRPr lang="en-US" sz="1900" dirty="0">
                         <a:latin typeface="Calibri" charset="0"/>
                         <a:ea typeface="Calibri" charset="0"/>
                         <a:cs typeface="Calibri" charset="0"/>
@@ -9588,7 +9590,7 @@
                   </a:tcPr>
                 </a:tc>
               </a:tr>
-              <a:tr h="0">
+              <a:tr h="594360">
                 <a:tc>
                   <a:txBody>
                     <a:bodyPr/>
@@ -9598,7 +9600,7 @@
                         <a:buNone/>
                       </a:pPr>
                       <a:r>
-                        <a:rPr lang="en-US" sz="1600" dirty="0">
+                        <a:rPr lang="en-US" sz="1900" dirty="0">
                           <a:solidFill>
                             <a:srgbClr val="FFFFFF"/>
                           </a:solidFill>
@@ -9608,7 +9610,7 @@
                         </a:rPr>
                         <a:t>Data Analysis &amp; Visualization</a:t>
                       </a:r>
-                      <a:endParaRPr lang="en-US" sz="1600" dirty="0">
+                      <a:endParaRPr lang="en-US" sz="1900" dirty="0">
                         <a:latin typeface="Calibri" charset="0"/>
                         <a:ea typeface="Calibri" charset="0"/>
                         <a:cs typeface="Calibri" charset="0"/>
@@ -9666,7 +9668,7 @@
                         <a:buNone/>
                       </a:pPr>
                       <a:r>
-                        <a:rPr lang="en-US" sz="1600" dirty="0">
+                        <a:rPr lang="en-US" sz="1900" dirty="0">
                           <a:solidFill>
                             <a:srgbClr val="FFFFFF"/>
                           </a:solidFill>
@@ -9676,7 +9678,7 @@
                         </a:rPr>
                         <a:t>14%</a:t>
                       </a:r>
-                      <a:endParaRPr lang="en-US" sz="1600" dirty="0">
+                      <a:endParaRPr lang="en-US" sz="1900" dirty="0">
                         <a:latin typeface="Calibri" charset="0"/>
                         <a:ea typeface="Calibri" charset="0"/>
                         <a:cs typeface="Calibri" charset="0"/>
@@ -9734,7 +9736,7 @@
                         <a:buNone/>
                       </a:pPr>
                       <a:r>
-                        <a:rPr lang="en-US" sz="1600" dirty="0">
+                        <a:rPr lang="en-US" sz="1900" dirty="0">
                           <a:solidFill>
                             <a:srgbClr val="FFFFFF"/>
                           </a:solidFill>
@@ -9744,7 +9746,7 @@
                         </a:rPr>
                         <a:t>M01 EDA, M03 NLP, RAPIDS</a:t>
                       </a:r>
-                      <a:endParaRPr lang="en-US" sz="1600" dirty="0">
+                      <a:endParaRPr lang="en-US" sz="1900" dirty="0">
                         <a:latin typeface="Calibri" charset="0"/>
                         <a:ea typeface="Calibri" charset="0"/>
                         <a:cs typeface="Calibri" charset="0"/>
@@ -9802,7 +9804,7 @@
                         <a:buNone/>
                       </a:pPr>
                       <a:r>
-                        <a:rPr lang="en-US" sz="1600" b="1" dirty="0">
+                        <a:rPr lang="en-US" sz="1900" b="1" dirty="0">
                           <a:solidFill>
                             <a:srgbClr val="76B900"/>
                           </a:solidFill>
@@ -9812,7 +9814,7 @@
                         </a:rPr>
                         <a:t>Tercakup</a:t>
                       </a:r>
-                      <a:endParaRPr lang="en-US" sz="1600" dirty="0">
+                      <a:endParaRPr lang="en-US" sz="1900" dirty="0">
                         <a:latin typeface="Calibri" charset="0"/>
                         <a:ea typeface="Calibri" charset="0"/>
                         <a:cs typeface="Calibri" charset="0"/>
@@ -9862,7 +9864,7 @@
                   </a:tcPr>
                 </a:tc>
               </a:tr>
-              <a:tr h="0">
+              <a:tr h="594360">
                 <a:tc>
                   <a:txBody>
                     <a:bodyPr/>
@@ -9872,7 +9874,7 @@
                         <a:buNone/>
                       </a:pPr>
                       <a:r>
-                        <a:rPr lang="en-US" sz="1600" dirty="0">
+                        <a:rPr lang="en-US" sz="1900" dirty="0">
                           <a:solidFill>
                             <a:srgbClr val="FFFFFF"/>
                           </a:solidFill>
@@ -9882,7 +9884,7 @@
                         </a:rPr>
                         <a:t>Trustworthy AI</a:t>
                       </a:r>
-                      <a:endParaRPr lang="en-US" sz="1600" dirty="0">
+                      <a:endParaRPr lang="en-US" sz="1900" dirty="0">
                         <a:latin typeface="Calibri" charset="0"/>
                         <a:ea typeface="Calibri" charset="0"/>
                         <a:cs typeface="Calibri" charset="0"/>
@@ -9940,7 +9942,7 @@
                         <a:buNone/>
                       </a:pPr>
                       <a:r>
-                        <a:rPr lang="en-US" sz="1600" dirty="0">
+                        <a:rPr lang="en-US" sz="1900" dirty="0">
                           <a:solidFill>
                             <a:srgbClr val="FFFFFF"/>
                           </a:solidFill>
@@ -9950,7 +9952,7 @@
                         </a:rPr>
                         <a:t>10%</a:t>
                       </a:r>
-                      <a:endParaRPr lang="en-US" sz="1600" dirty="0">
+                      <a:endParaRPr lang="en-US" sz="1900" dirty="0">
                         <a:latin typeface="Calibri" charset="0"/>
                         <a:ea typeface="Calibri" charset="0"/>
                         <a:cs typeface="Calibri" charset="0"/>
@@ -10008,7 +10010,7 @@
                         <a:buNone/>
                       </a:pPr>
                       <a:r>
-                        <a:rPr lang="en-US" sz="1600" dirty="0">
+                        <a:rPr lang="en-US" sz="1900" dirty="0">
                           <a:solidFill>
                             <a:srgbClr val="FFFFFF"/>
                           </a:solidFill>
@@ -10018,7 +10020,7 @@
                         </a:rPr>
                         <a:t>M06 fairness, guardrails, privasi</a:t>
                       </a:r>
-                      <a:endParaRPr lang="en-US" sz="1600" dirty="0">
+                      <a:endParaRPr lang="en-US" sz="1900" dirty="0">
                         <a:latin typeface="Calibri" charset="0"/>
                         <a:ea typeface="Calibri" charset="0"/>
                         <a:cs typeface="Calibri" charset="0"/>
@@ -10076,7 +10078,7 @@
                         <a:buNone/>
                       </a:pPr>
                       <a:r>
-                        <a:rPr lang="en-US" sz="1600" b="1" dirty="0">
+                        <a:rPr lang="en-US" sz="1900" b="1" dirty="0">
                           <a:solidFill>
                             <a:srgbClr val="76B900"/>
                           </a:solidFill>
@@ -10086,7 +10088,7 @@
                         </a:rPr>
                         <a:t>Tercakup</a:t>
                       </a:r>
-                      <a:endParaRPr lang="en-US" sz="1600" dirty="0">
+                      <a:endParaRPr lang="en-US" sz="1900" dirty="0">
                         <a:latin typeface="Calibri" charset="0"/>
                         <a:ea typeface="Calibri" charset="0"/>
                         <a:cs typeface="Calibri" charset="0"/>
@@ -11712,13 +11714,13 @@
           <a:p>
             <a:pPr marL="342900" indent="-342900">
               <a:spcAft>
-                <a:spcPts val="1200"/>
+                <a:spcPts val="2400"/>
               </a:spcAft>
               <a:buSzPct val="100000"/>
               <a:buChar char="•"/>
             </a:pPr>
             <a:r>
-              <a:rPr lang="en-US" sz="2200" dirty="0">
+              <a:rPr lang="en-US" sz="2400" dirty="0">
                 <a:solidFill>
                   <a:srgbClr val="FFFFFF"/>
                 </a:solidFill>
@@ -11728,18 +11730,18 @@
               </a:rPr>
               <a:t>Baca examination policy NVIDIA dan siapkan perangkat sebelum jadwal ujian.</a:t>
             </a:r>
-            <a:endParaRPr lang="en-US" sz="2200" dirty="0"/>
+            <a:endParaRPr lang="en-US" sz="2400" dirty="0"/>
           </a:p>
           <a:p>
             <a:pPr marL="342900" indent="-342900">
               <a:spcAft>
-                <a:spcPts val="1200"/>
+                <a:spcPts val="2400"/>
               </a:spcAft>
               <a:buSzPct val="100000"/>
               <a:buChar char="•"/>
             </a:pPr>
             <a:r>
-              <a:rPr lang="en-US" sz="2200" dirty="0">
+              <a:rPr lang="en-US" sz="2400" dirty="0">
                 <a:solidFill>
                   <a:srgbClr val="FFFFFF"/>
                 </a:solidFill>
@@ -11749,18 +11751,18 @@
               </a:rPr>
               <a:t>Rata-rata sekitar satu menit per soal. Jangan terpaku di satu soal.</a:t>
             </a:r>
-            <a:endParaRPr lang="en-US" sz="2200" dirty="0"/>
+            <a:endParaRPr lang="en-US" sz="2400" dirty="0"/>
           </a:p>
           <a:p>
             <a:pPr marL="342900" indent="-342900">
               <a:spcAft>
-                <a:spcPts val="1200"/>
+                <a:spcPts val="2400"/>
               </a:spcAft>
               <a:buSzPct val="100000"/>
               <a:buChar char="•"/>
             </a:pPr>
             <a:r>
-              <a:rPr lang="en-US" sz="2200" dirty="0">
+              <a:rPr lang="en-US" sz="2400" dirty="0">
                 <a:solidFill>
                   <a:srgbClr val="FFFFFF"/>
                 </a:solidFill>
@@ -11770,18 +11772,18 @@
               </a:rPr>
               <a:t>Perhatikan kata kunci soal: best, most likely, first, NOT.</a:t>
             </a:r>
-            <a:endParaRPr lang="en-US" sz="2200" dirty="0"/>
+            <a:endParaRPr lang="en-US" sz="2400" dirty="0"/>
           </a:p>
           <a:p>
             <a:pPr marL="342900" indent="-342900">
               <a:spcAft>
-                <a:spcPts val="1200"/>
+                <a:spcPts val="2400"/>
               </a:spcAft>
               <a:buSzPct val="100000"/>
               <a:buChar char="•"/>
             </a:pPr>
             <a:r>
-              <a:rPr lang="en-US" sz="2200" dirty="0">
+              <a:rPr lang="en-US" sz="2400" dirty="0">
                 <a:solidFill>
                   <a:srgbClr val="FFFFFF"/>
                 </a:solidFill>
@@ -11791,18 +11793,18 @@
               </a:rPr>
               <a:t>Singkirkan pilihan yang jelas salah, lalu bandingkan sisanya.</a:t>
             </a:r>
-            <a:endParaRPr lang="en-US" sz="2200" dirty="0"/>
+            <a:endParaRPr lang="en-US" sz="2400" dirty="0"/>
           </a:p>
           <a:p>
             <a:pPr marL="342900" indent="-342900">
               <a:spcAft>
-                <a:spcPts val="1200"/>
+                <a:spcPts val="2400"/>
               </a:spcAft>
               <a:buSzPct val="100000"/>
               <a:buChar char="•"/>
             </a:pPr>
             <a:r>
-              <a:rPr lang="en-US" sz="2200" dirty="0">
+              <a:rPr lang="en-US" sz="2400" dirty="0">
                 <a:solidFill>
                   <a:srgbClr val="FFFFFF"/>
                 </a:solidFill>
@@ -11812,7 +11814,7 @@
               </a:rPr>
               <a:t>Pahami fungsi tiap produk NVIDIA: Triton, TensorRT, NeMo, NIM, RAPIDS.</a:t>
             </a:r>
-            <a:endParaRPr lang="en-US" sz="2200" dirty="0"/>
+            <a:endParaRPr lang="en-US" sz="2400" dirty="0"/>
           </a:p>
         </p:txBody>
       </p:sp>

</xml_diff>